<commit_message>
Regenerate SynthesizeBrain.pptx from the portable build_pptx.js
Verifies the path.resolve(__dirname, '..') approach works end-to-end.
Content unchanged — just a fresh build from the cleaned-up script.

Co-Authored-By: Claude Opus 4.7 (1M context) <noreply@anthropic.com>
</commit_message>
<xml_diff>
--- a/docs/SynthesizeBrain.pptx
+++ b/docs/SynthesizeBrain.pptx
@@ -1767,7 +1767,7 @@
       </p:grpSpPr>
       <p:pic>
         <p:nvPicPr>
-          <p:cNvPr id="2" name="Image 0" descr="C:\Users\USER\Work\SynthesizeBrain\output\output_N500_K150_R156_s91136998\mip.png">    </p:cNvPr>
+          <p:cNvPr id="2" name="Image 0" descr="C:\Users\USER\Work\SynthesizeBrain\output\output_N500_K133_R136_s3806857573\mip.png">    </p:cNvPr>
           <p:cNvPicPr>
             <a:picLocks noChangeAspect="1"/>
           </p:cNvPicPr>
@@ -8270,7 +8270,7 @@
       </p:sp>
       <p:pic>
         <p:nvPicPr>
-          <p:cNvPr id="6" name="Image 0" descr="C:\Users\USER\Work\SynthesizeBrain\output\output_N500_K150_R156_s91136998\mip.png">    </p:cNvPr>
+          <p:cNvPr id="6" name="Image 0" descr="C:\Users\USER\Work\SynthesizeBrain\output\output_N500_K133_R136_s3806857573\mip.png">    </p:cNvPr>
           <p:cNvPicPr>
             <a:picLocks noChangeAspect="1"/>
           </p:cNvPicPr>

</xml_diff>